<commit_message>
Intro ING: la plataforma de encuentro pasa de Google Meet a Microsoft Teams
Solo el nombre de la plataforma en el material (correo, calendario, guiones
docentes, configuracion de ExamLab): el docente ya tiene el enlace en su
propio calendario de Teams, no se automatiza nada nuevo aqui. El .gs que crea
los encuentros en Google Calendar sigue igual a proposito (crea el bloque en
el calendario personal del docente; no genera salas de Teams).
</commit_message>
<xml_diff>
--- a/Introduccion a la Ingenieria/Clases/Presentacion del Curso - Introduccion a la Ingenieria - LB141F.pptx
+++ b/Introduccion a la Ingenieria/Clases/Presentacion del Curso - Introduccion a la Ingenieria - LB141F.pptx
@@ -3448,7 +3448,7 @@
                 </a:solidFill>
                 <a:latin typeface="Calibri"/>
               </a:rPr>
-              <a:t>Google Meet</a:t>
+              <a:t>Microsoft Teams</a:t>
             </a:r>
             <a:r>
               <a:rPr sz="1500" b="0" i="0">
@@ -6827,7 +6827,7 @@
                 </a:solidFill>
                 <a:latin typeface="Calibri"/>
               </a:rPr>
-              <a:t>UNIAJC · Ingeniería de Sistemas · Virtual sincrónica por Google Meet</a:t>
+              <a:t>UNIAJC · Ingeniería de Sistemas · Virtual sincrónica por Microsoft Teams</a:t>
             </a:r>
           </a:p>
         </p:txBody>
@@ -9171,7 +9171,7 @@
                 </a:solidFill>
                 <a:latin typeface="Calibri"/>
               </a:rPr>
-              <a:t> — Cinco salas de grupo en Meet, el docente rota por todas</a:t>
+              <a:t> — Cinco salas de grupo en Teams, el docente rota por todas</a:t>
             </a:r>
           </a:p>
         </p:txBody>
@@ -10058,7 +10058,7 @@
                           </a:solidFill>
                           <a:latin typeface="Calibri"/>
                         </a:rPr>
-                        <a:t>Los 5 equipos pasan a sus salas de grupo de Meet y trabajan en paralelo sobre la misma consigna, cada uno en su documento en la nube. El docente entra y sale de las cinco salas (unos 3 min en cada una). A los 15 min se avisa por el chat general y se cierran las salas.</a:t>
+                        <a:t>Los 5 equipos pasan a sus salas de grupo de Teams y trabajan en paralelo sobre la misma consigna, cada uno en su documento en la nube. El docente entra y sale de las cinco salas (unos 3 min en cada una). A los 15 min se avisa por el chat general y se cierran las salas.</a:t>
                       </a:r>
                     </a:p>
                   </a:txBody>
@@ -11294,7 +11294,7 @@
                 </a:solidFill>
                 <a:latin typeface="Calibri"/>
               </a:rPr>
-              <a:t>GM</a:t>
+              <a:t>MT</a:t>
             </a:r>
           </a:p>
         </p:txBody>
@@ -11327,7 +11327,7 @@
                 </a:solidFill>
                 <a:latin typeface="Calibri"/>
               </a:rPr>
-              <a:t>Google Meet</a:t>
+              <a:t>Microsoft Teams</a:t>
             </a:r>
           </a:p>
           <a:p>

</xml_diff>